<commit_message>
Here is the change to a file
</commit_message>
<xml_diff>
--- a/SchambergBrandon_GPA1-B.pptx
+++ b/SchambergBrandon_GPA1-B.pptx
@@ -9,6 +9,7 @@
     <p:sldId id="257" r:id="rId3"/>
     <p:sldId id="258" r:id="rId4"/>
     <p:sldId id="259" r:id="rId5"/>
+    <p:sldId id="260" r:id="rId6"/>
   </p:sldIdLst>
   <p:sldSz cx="12192000" cy="6858000"/>
   <p:notesSz cx="6858000" cy="9144000"/>
@@ -416,7 +417,7 @@
           <a:p>
             <a:fld id="{846CE7D5-CF57-46EF-B807-FDD0502418D4}" type="datetimeFigureOut">
               <a:rPr lang="en-US" smtClean="0"/>
-              <a:t>5/11/2026</a:t>
+              <a:t>7/23/2026</a:t>
             </a:fld>
             <a:endParaRPr lang="en-US"/>
           </a:p>
@@ -586,7 +587,7 @@
           <a:p>
             <a:fld id="{846CE7D5-CF57-46EF-B807-FDD0502418D4}" type="datetimeFigureOut">
               <a:rPr lang="en-US" smtClean="0"/>
-              <a:t>5/11/2026</a:t>
+              <a:t>7/23/2026</a:t>
             </a:fld>
             <a:endParaRPr lang="en-US"/>
           </a:p>
@@ -766,7 +767,7 @@
           <a:p>
             <a:fld id="{846CE7D5-CF57-46EF-B807-FDD0502418D4}" type="datetimeFigureOut">
               <a:rPr lang="en-US" smtClean="0"/>
-              <a:t>5/11/2026</a:t>
+              <a:t>7/23/2026</a:t>
             </a:fld>
             <a:endParaRPr lang="en-US"/>
           </a:p>
@@ -936,7 +937,7 @@
           <a:p>
             <a:fld id="{846CE7D5-CF57-46EF-B807-FDD0502418D4}" type="datetimeFigureOut">
               <a:rPr lang="en-US" smtClean="0"/>
-              <a:t>5/11/2026</a:t>
+              <a:t>7/23/2026</a:t>
             </a:fld>
             <a:endParaRPr lang="en-US"/>
           </a:p>
@@ -1182,7 +1183,7 @@
           <a:p>
             <a:fld id="{846CE7D5-CF57-46EF-B807-FDD0502418D4}" type="datetimeFigureOut">
               <a:rPr lang="en-US" smtClean="0"/>
-              <a:t>5/11/2026</a:t>
+              <a:t>7/23/2026</a:t>
             </a:fld>
             <a:endParaRPr lang="en-US"/>
           </a:p>
@@ -1414,7 +1415,7 @@
           <a:p>
             <a:fld id="{846CE7D5-CF57-46EF-B807-FDD0502418D4}" type="datetimeFigureOut">
               <a:rPr lang="en-US" smtClean="0"/>
-              <a:t>5/11/2026</a:t>
+              <a:t>7/23/2026</a:t>
             </a:fld>
             <a:endParaRPr lang="en-US"/>
           </a:p>
@@ -1781,7 +1782,7 @@
           <a:p>
             <a:fld id="{846CE7D5-CF57-46EF-B807-FDD0502418D4}" type="datetimeFigureOut">
               <a:rPr lang="en-US" smtClean="0"/>
-              <a:t>5/11/2026</a:t>
+              <a:t>7/23/2026</a:t>
             </a:fld>
             <a:endParaRPr lang="en-US"/>
           </a:p>
@@ -1899,7 +1900,7 @@
           <a:p>
             <a:fld id="{846CE7D5-CF57-46EF-B807-FDD0502418D4}" type="datetimeFigureOut">
               <a:rPr lang="en-US" smtClean="0"/>
-              <a:t>5/11/2026</a:t>
+              <a:t>7/23/2026</a:t>
             </a:fld>
             <a:endParaRPr lang="en-US"/>
           </a:p>
@@ -1994,7 +1995,7 @@
           <a:p>
             <a:fld id="{846CE7D5-CF57-46EF-B807-FDD0502418D4}" type="datetimeFigureOut">
               <a:rPr lang="en-US" smtClean="0"/>
-              <a:t>5/11/2026</a:t>
+              <a:t>7/23/2026</a:t>
             </a:fld>
             <a:endParaRPr lang="en-US"/>
           </a:p>
@@ -2271,7 +2272,7 @@
           <a:p>
             <a:fld id="{846CE7D5-CF57-46EF-B807-FDD0502418D4}" type="datetimeFigureOut">
               <a:rPr lang="en-US" smtClean="0"/>
-              <a:t>5/11/2026</a:t>
+              <a:t>7/23/2026</a:t>
             </a:fld>
             <a:endParaRPr lang="en-US"/>
           </a:p>
@@ -2528,7 +2529,7 @@
           <a:p>
             <a:fld id="{846CE7D5-CF57-46EF-B807-FDD0502418D4}" type="datetimeFigureOut">
               <a:rPr lang="en-US" smtClean="0"/>
-              <a:t>5/11/2026</a:t>
+              <a:t>7/23/2026</a:t>
             </a:fld>
             <a:endParaRPr lang="en-US"/>
           </a:p>
@@ -2741,7 +2742,7 @@
           <a:p>
             <a:fld id="{846CE7D5-CF57-46EF-B807-FDD0502418D4}" type="datetimeFigureOut">
               <a:rPr lang="en-US" smtClean="0"/>
-              <a:t>5/11/2026</a:t>
+              <a:t>7/23/2026</a:t>
             </a:fld>
             <a:endParaRPr lang="en-US"/>
           </a:p>
@@ -3398,6 +3399,89 @@
 </p:sld>
 </file>
 
+<file path=ppt/slides/slide5.xml><?xml version="1.0" encoding="utf-8"?>
+<p:sld xmlns:a="http://schemas.openxmlformats.org/drawingml/2006/main" xmlns:r="http://schemas.openxmlformats.org/officeDocument/2006/relationships" xmlns:p="http://schemas.openxmlformats.org/presentationml/2006/main">
+  <p:cSld>
+    <p:spTree>
+      <p:nvGrpSpPr>
+        <p:cNvPr id="1" name=""/>
+        <p:cNvGrpSpPr/>
+        <p:nvPr/>
+      </p:nvGrpSpPr>
+      <p:grpSpPr>
+        <a:xfrm>
+          <a:off x="0" y="0"/>
+          <a:ext cx="0" cy="0"/>
+          <a:chOff x="0" y="0"/>
+          <a:chExt cx="0" cy="0"/>
+        </a:xfrm>
+      </p:grpSpPr>
+      <p:sp>
+        <p:nvSpPr>
+          <p:cNvPr id="2" name="Title 1">
+            <a:extLst>
+              <a:ext uri="{FF2B5EF4-FFF2-40B4-BE49-F238E27FC236}">
+                <a16:creationId xmlns:a16="http://schemas.microsoft.com/office/drawing/2014/main" id="{0451B00C-E278-47DF-ABF4-872D8AFBA508}"/>
+              </a:ext>
+            </a:extLst>
+          </p:cNvPr>
+          <p:cNvSpPr>
+            <a:spLocks noGrp="1"/>
+          </p:cNvSpPr>
+          <p:nvPr>
+            <p:ph type="title"/>
+          </p:nvPr>
+        </p:nvSpPr>
+        <p:spPr/>
+        <p:txBody>
+          <a:bodyPr/>
+          <a:lstStyle/>
+          <a:p>
+            <a:r>
+              <a:rPr lang="en-US" dirty="0"/>
+              <a:t>Text added for git diff</a:t>
+            </a:r>
+          </a:p>
+        </p:txBody>
+      </p:sp>
+      <p:sp>
+        <p:nvSpPr>
+          <p:cNvPr id="3" name="Content Placeholder 2">
+            <a:extLst>
+              <a:ext uri="{FF2B5EF4-FFF2-40B4-BE49-F238E27FC236}">
+                <a16:creationId xmlns:a16="http://schemas.microsoft.com/office/drawing/2014/main" id="{50F66023-B4F2-44B8-8F83-4C918682D29B}"/>
+              </a:ext>
+            </a:extLst>
+          </p:cNvPr>
+          <p:cNvSpPr>
+            <a:spLocks noGrp="1"/>
+          </p:cNvSpPr>
+          <p:nvPr>
+            <p:ph idx="1"/>
+          </p:nvPr>
+        </p:nvSpPr>
+        <p:spPr/>
+        <p:txBody>
+          <a:bodyPr/>
+          <a:lstStyle/>
+          <a:p>
+            <a:endParaRPr lang="en-US"/>
+          </a:p>
+        </p:txBody>
+      </p:sp>
+    </p:spTree>
+    <p:extLst>
+      <p:ext uri="{BB962C8B-B14F-4D97-AF65-F5344CB8AC3E}">
+        <p14:creationId xmlns:p14="http://schemas.microsoft.com/office/powerpoint/2010/main" val="717243565"/>
+      </p:ext>
+    </p:extLst>
+  </p:cSld>
+  <p:clrMapOvr>
+    <a:masterClrMapping/>
+  </p:clrMapOvr>
+</p:sld>
+</file>
+
 <file path=ppt/theme/theme1.xml><?xml version="1.0" encoding="utf-8"?>
 <a:theme xmlns:a="http://schemas.openxmlformats.org/drawingml/2006/main" name="office theme">
   <a:themeElements>

</xml_diff>